<commit_message>
Add in OLE and RTF support
</commit_message>
<xml_diff>
--- a/test/fixtures/docs/actions.pptx
+++ b/test/fixtures/docs/actions.pptx
@@ -143,7 +143,7 @@
         <p:txBody>
           <a:bodyPr/>
           <a:p>
-            <a:fld id="{58A62A18-8442-43F3-9B24-7167CF3E14D2}" type="slidenum">
+            <a:fld id="{00000000-0000-4000-8000-000000000002}" type="slidenum">
               <a:t>&lt;#&gt;</a:t>
             </a:fld>
           </a:p>
@@ -628,7 +628,7 @@
             <a:pPr indent="0" algn="r">
               <a:buNone/>
             </a:pPr>
-            <a:fld id="{57A0C1A6-649D-407D-A694-4283DF03FDBD}" type="slidenum">
+            <a:fld id="{00000000-0000-4000-8000-000000000001}" type="slidenum">
               <a:rPr b="0" lang="en-US" sz="1400" spc="-1" strike="noStrike">
                 <a:solidFill>
                   <a:srgbClr val="000000"/>

</xml_diff>